<commit_message>
docs(deck): closing slide lists where to find everything
Replaces the 'Go deeper' closing slide with 'Where to find everything': the GitHub repo, the FAQ, install instructions (the FAQ's Download and install section and getting-started.md, since the README one-liner is fixed only in PR #3247), and the demo guide (the in-app Guided Demo Track at /demo-track and docs/user-guide/AGENT_SHOWCASE_DEMO_SCENARIOS.md), plus the three spun-out tools. Rendered through PowerPoint and checked.

Co-Authored-By: Claude Opus 5 (1M context) <noreply@anthropic.com>
</commit_message>
<xml_diff>
--- a/docs/resources/AI-Demo-Overview.pptx
+++ b/docs/resources/AI-Demo-Overview.pptx
@@ -1818,7 +1818,11 @@
           <a:p>
             <a:r>
               <a:rPr lang="en-US" dirty="0"/>
-              <a:t>The three standalone repos run with no PingOne tenant and no demo stack; their canonical source is in this repo (standalone/ and demo_llm_proxy/).</a:t>
+              <a:t>GitHub: https://github.com/curtismu7/AI-DEMO2 (public).
+FAQ: https://github.com/curtismu7/AI-DEMO2/blob/main/docs/FAQ.md
+Install: the FAQ's 'Download and install' section (https://github.com/curtismu7/AI-DEMO2/blob/main/docs/FAQ.md#download-and-install) and docs/user-guide/getting-started.md. The README's one-line install points at a retired repo URL until PR #3247 merges, so send people to the FAQ for now.
+Demo guide: the in-app Guided Demo Track at /demo-track (https://local.ping-devops.com:4000/demo-track locally, or the SE cluster's /demo-track when deployed) and the click-by-click walkthroughs in docs/user-guide/AGENT_SHOWCASE_DEMO_SCENARIOS.md.
+The three standalone tools run with no PingOne tenant and no demo stack; their canonical source is in this repo (standalone/ and demo_llm_proxy/).</a:t>
             </a:r>
             <a:endParaRPr lang="en-US" dirty="0"/>
           </a:p>
@@ -36299,7 +36303,7 @@
         </p:nvSpPr>
         <p:spPr>
           <a:xfrm>
-            <a:off x="914400" y="1143000"/>
+            <a:off x="914400" y="868680"/>
             <a:ext cx="7315200" cy="640080"/>
           </a:xfrm>
           <a:prstGeom prst="rect">
@@ -36316,7 +36320,7 @@
               <a:buNone/>
             </a:pPr>
             <a:r>
-              <a:rPr lang="en-US" sz="3200" b="1" dirty="0">
+              <a:rPr lang="en-US" sz="3000" b="1" dirty="0">
                 <a:solidFill>
                   <a:srgbClr val="FFFFFF"/>
                 </a:solidFill>
@@ -36324,9 +36328,9 @@
                 <a:ea typeface="Montserrat" pitchFamily="34" charset="-122"/>
                 <a:cs typeface="Montserrat" pitchFamily="34" charset="-120"/>
               </a:rPr>
-              <a:t>Go deeper</a:t>
+              <a:t>Where to find everything</a:t>
             </a:r>
-            <a:endParaRPr lang="en-US" sz="3200" dirty="0"/>
+            <a:endParaRPr lang="en-US" sz="3000" dirty="0"/>
           </a:p>
         </p:txBody>
       </p:sp>
@@ -36338,8 +36342,8 @@
         </p:nvSpPr>
         <p:spPr>
           <a:xfrm>
-            <a:off x="914400" y="2103120"/>
-            <a:ext cx="457200" cy="457200"/>
+            <a:off x="914400" y="1737360"/>
+            <a:ext cx="402336" cy="402336"/>
           </a:xfrm>
           <a:prstGeom prst="ellipse">
             <a:avLst/>
@@ -36366,8 +36370,8 @@
         </p:blipFill>
         <p:spPr>
           <a:xfrm>
-            <a:off x="1037844" y="2226564"/>
-            <a:ext cx="210312" cy="210312"/>
+            <a:off x="1023031" y="1845991"/>
+            <a:ext cx="185075" cy="185075"/>
           </a:xfrm>
           <a:prstGeom prst="rect">
             <a:avLst/>
@@ -36382,8 +36386,8 @@
         </p:nvSpPr>
         <p:spPr>
           <a:xfrm>
-            <a:off x="914400" y="2670048"/>
-            <a:ext cx="2514600" cy="329184"/>
+            <a:off x="1481328" y="1737360"/>
+            <a:ext cx="1920240" cy="402336"/>
           </a:xfrm>
           <a:prstGeom prst="rect">
             <a:avLst/>
@@ -36399,7 +36403,7 @@
               <a:buNone/>
             </a:pPr>
             <a:r>
-              <a:rPr lang="en-US" sz="1400" b="1" dirty="0">
+              <a:rPr lang="en-US" sz="1250" b="1" dirty="0">
                 <a:solidFill>
                   <a:srgbClr val="FFFFFF"/>
                 </a:solidFill>
@@ -36407,9 +36411,9 @@
                 <a:ea typeface="Montserrat" pitchFamily="34" charset="-122"/>
                 <a:cs typeface="Montserrat" pitchFamily="34" charset="-120"/>
               </a:rPr>
-              <a:t>Run it</a:t>
+              <a:t>GitHub</a:t>
             </a:r>
-            <a:endParaRPr lang="en-US" sz="1400" dirty="0"/>
+            <a:endParaRPr lang="en-US" sz="1250" dirty="0"/>
           </a:p>
         </p:txBody>
       </p:sp>
@@ -36421,134 +36425,8 @@
         </p:nvSpPr>
         <p:spPr>
           <a:xfrm>
-            <a:off x="914400" y="3054096"/>
-            <a:ext cx="2514600" cy="1005840"/>
-          </a:xfrm>
-          <a:prstGeom prst="rect">
-            <a:avLst/>
-          </a:prstGeom>
-          <a:noFill/>
-          <a:ln/>
-        </p:spPr>
-        <p:txBody>
-          <a:bodyPr wrap="square" lIns="0" tIns="0" rIns="0" bIns="0" rtlCol="0" anchor="t"/>
-          <a:lstStyle/>
-          <a:p>
-            <a:pPr indent="0" marL="0">
-              <a:spcAft>
-                <a:spcPts val="400"/>
-              </a:spcAft>
-              <a:buNone/>
-            </a:pPr>
-            <a:r>
-              <a:rPr lang="en-US" sz="1050" dirty="0">
-                <a:solidFill>
-                  <a:srgbClr val="B9C6D6"/>
-                </a:solidFill>
-                <a:latin typeface="Calibri" pitchFamily="34" charset="0"/>
-                <a:ea typeface="Calibri" pitchFamily="34" charset="-122"/>
-                <a:cs typeface="Calibri" pitchFamily="34" charset="-120"/>
-              </a:rPr>
-              <a:t>docs/FAQ.md</a:t>
-            </a:r>
-            <a:endParaRPr lang="en-US" sz="1050" dirty="0"/>
-          </a:p>
-          <a:p>
-            <a:pPr indent="0" marL="0">
-              <a:spcAft>
-                <a:spcPts val="400"/>
-              </a:spcAft>
-              <a:buNone/>
-            </a:pPr>
-            <a:r>
-              <a:rPr lang="en-US" sz="1050" dirty="0">
-                <a:solidFill>
-                  <a:srgbClr val="B9C6D6"/>
-                </a:solidFill>
-                <a:latin typeface="Calibri" pitchFamily="34" charset="0"/>
-                <a:ea typeface="Calibri" pitchFamily="34" charset="-122"/>
-                <a:cs typeface="Calibri" pitchFamily="34" charset="-120"/>
-              </a:rPr>
-              <a:t>README.md</a:t>
-            </a:r>
-            <a:endParaRPr lang="en-US" sz="1050" dirty="0"/>
-          </a:p>
-          <a:p>
-            <a:pPr indent="0" marL="0">
-              <a:spcAft>
-                <a:spcPts val="400"/>
-              </a:spcAft>
-              <a:buNone/>
-            </a:pPr>
-            <a:r>
-              <a:rPr lang="en-US" sz="1050" dirty="0">
-                <a:solidFill>
-                  <a:srgbClr val="B9C6D6"/>
-                </a:solidFill>
-                <a:latin typeface="Calibri" pitchFamily="34" charset="0"/>
-                <a:ea typeface="Calibri" pitchFamily="34" charset="-122"/>
-                <a:cs typeface="Calibri" pitchFamily="34" charset="-120"/>
-              </a:rPr>
-              <a:t>docs/user-guide/getting-started.md</a:t>
-            </a:r>
-            <a:endParaRPr lang="en-US" sz="1050" dirty="0"/>
-          </a:p>
-        </p:txBody>
-      </p:sp>
-      <p:sp>
-        <p:nvSpPr>
-          <p:cNvPr id="11" name="Shape 8"/>
-          <p:cNvSpPr/>
-          <p:nvPr/>
-        </p:nvSpPr>
-        <p:spPr>
-          <a:xfrm>
-            <a:off x="3520440" y="2103120"/>
-            <a:ext cx="457200" cy="457200"/>
-          </a:xfrm>
-          <a:prstGeom prst="ellipse">
-            <a:avLst/>
-          </a:prstGeom>
-          <a:solidFill>
-            <a:srgbClr val="C8102E"/>
-          </a:solidFill>
-          <a:ln/>
-        </p:spPr>
-      </p:sp>
-      <p:pic>
-        <p:nvPicPr>
-          <p:cNvPr id="12" name="Image 1" descr="preencoded.png">    </p:cNvPr>
-          <p:cNvPicPr>
-            <a:picLocks noChangeAspect="1"/>
-          </p:cNvPicPr>
-          <p:nvPr/>
-        </p:nvPicPr>
-        <p:blipFill>
-          <a:blip r:embed="rId2"/>
-          <a:stretch>
-            <a:fillRect/>
-          </a:stretch>
-        </p:blipFill>
-        <p:spPr>
-          <a:xfrm>
-            <a:off x="3643884" y="2226564"/>
-            <a:ext cx="210312" cy="210312"/>
-          </a:xfrm>
-          <a:prstGeom prst="rect">
-            <a:avLst/>
-          </a:prstGeom>
-        </p:spPr>
-      </p:pic>
-      <p:sp>
-        <p:nvSpPr>
-          <p:cNvPr id="13" name="Text 9"/>
-          <p:cNvSpPr/>
-          <p:nvPr/>
-        </p:nvSpPr>
-        <p:spPr>
-          <a:xfrm>
-            <a:off x="3520440" y="2670048"/>
-            <a:ext cx="2514600" cy="329184"/>
+            <a:off x="3429000" y="1700784"/>
+            <a:ext cx="4846320" cy="475488"/>
           </a:xfrm>
           <a:prstGeom prst="rect">
             <a:avLst/>
@@ -36564,49 +36442,7 @@
               <a:buNone/>
             </a:pPr>
             <a:r>
-              <a:rPr lang="en-US" sz="1400" b="1" dirty="0">
-                <a:solidFill>
-                  <a:srgbClr val="FFFFFF"/>
-                </a:solidFill>
-                <a:latin typeface="Montserrat" pitchFamily="34" charset="0"/>
-                <a:ea typeface="Montserrat" pitchFamily="34" charset="-122"/>
-                <a:cs typeface="Montserrat" pitchFamily="34" charset="-120"/>
-              </a:rPr>
-              <a:t>Know the rules</a:t>
-            </a:r>
-            <a:endParaRPr lang="en-US" sz="1400" dirty="0"/>
-          </a:p>
-        </p:txBody>
-      </p:sp>
-      <p:sp>
-        <p:nvSpPr>
-          <p:cNvPr id="14" name="Text 10"/>
-          <p:cNvSpPr/>
-          <p:nvPr/>
-        </p:nvSpPr>
-        <p:spPr>
-          <a:xfrm>
-            <a:off x="3520440" y="3054096"/>
-            <a:ext cx="2514600" cy="1005840"/>
-          </a:xfrm>
-          <a:prstGeom prst="rect">
-            <a:avLst/>
-          </a:prstGeom>
-          <a:noFill/>
-          <a:ln/>
-        </p:spPr>
-        <p:txBody>
-          <a:bodyPr wrap="square" lIns="0" tIns="0" rIns="0" bIns="0" rtlCol="0" anchor="t"/>
-          <a:lstStyle/>
-          <a:p>
-            <a:pPr indent="0" marL="0">
-              <a:spcAft>
-                <a:spcPts val="400"/>
-              </a:spcAft>
-              <a:buNone/>
-            </a:pPr>
-            <a:r>
-              <a:rPr lang="en-US" sz="1050" dirty="0">
+              <a:rPr lang="en-US" sz="1200" dirty="0">
                 <a:solidFill>
                   <a:srgbClr val="B9C6D6"/>
                 </a:solidFill>
@@ -36614,62 +36450,22 @@
                 <a:ea typeface="Calibri" pitchFamily="34" charset="-122"/>
                 <a:cs typeface="Calibri" pitchFamily="34" charset="-120"/>
               </a:rPr>
-              <a:t>docs/ARCHITECTURE-TRUTHS.md</a:t>
+              <a:t>github.com/curtismu7/AI-DEMO2</a:t>
             </a:r>
-            <a:endParaRPr lang="en-US" sz="1050" dirty="0"/>
-          </a:p>
-          <a:p>
-            <a:pPr indent="0" marL="0">
-              <a:spcAft>
-                <a:spcPts val="400"/>
-              </a:spcAft>
-              <a:buNone/>
-            </a:pPr>
-            <a:r>
-              <a:rPr lang="en-US" sz="1050" dirty="0">
-                <a:solidFill>
-                  <a:srgbClr val="B9C6D6"/>
-                </a:solidFill>
-                <a:latin typeface="Calibri" pitchFamily="34" charset="0"/>
-                <a:ea typeface="Calibri" pitchFamily="34" charset="-122"/>
-                <a:cs typeface="Calibri" pitchFamily="34" charset="-120"/>
-              </a:rPr>
-              <a:t>REGRESSION_PLAN.md</a:t>
-            </a:r>
-            <a:endParaRPr lang="en-US" sz="1050" dirty="0"/>
-          </a:p>
-          <a:p>
-            <a:pPr indent="0" marL="0">
-              <a:spcAft>
-                <a:spcPts val="400"/>
-              </a:spcAft>
-              <a:buNone/>
-            </a:pPr>
-            <a:r>
-              <a:rPr lang="en-US" sz="1050" dirty="0">
-                <a:solidFill>
-                  <a:srgbClr val="B9C6D6"/>
-                </a:solidFill>
-                <a:latin typeface="Calibri" pitchFamily="34" charset="0"/>
-                <a:ea typeface="Calibri" pitchFamily="34" charset="-122"/>
-                <a:cs typeface="Calibri" pitchFamily="34" charset="-120"/>
-              </a:rPr>
-              <a:t>docs/use-cases/</a:t>
-            </a:r>
-            <a:endParaRPr lang="en-US" sz="1050" dirty="0"/>
+            <a:endParaRPr lang="en-US" sz="1200" dirty="0"/>
           </a:p>
         </p:txBody>
       </p:sp>
       <p:sp>
         <p:nvSpPr>
-          <p:cNvPr id="15" name="Shape 11"/>
+          <p:cNvPr id="11" name="Shape 8"/>
           <p:cNvSpPr/>
           <p:nvPr/>
         </p:nvSpPr>
         <p:spPr>
           <a:xfrm>
-            <a:off x="6126480" y="2103120"/>
-            <a:ext cx="457200" cy="457200"/>
+            <a:off x="914400" y="2322576"/>
+            <a:ext cx="402336" cy="402336"/>
           </a:xfrm>
           <a:prstGeom prst="ellipse">
             <a:avLst/>
@@ -36682,22 +36478,22 @@
       </p:sp>
       <p:pic>
         <p:nvPicPr>
-          <p:cNvPr id="16" name="Image 2" descr="preencoded.png">    </p:cNvPr>
+          <p:cNvPr id="12" name="Image 1" descr="preencoded.png">    </p:cNvPr>
           <p:cNvPicPr>
             <a:picLocks noChangeAspect="1"/>
           </p:cNvPicPr>
           <p:nvPr/>
         </p:nvPicPr>
         <p:blipFill>
-          <a:blip r:embed="rId3"/>
+          <a:blip r:embed="rId2"/>
           <a:stretch>
             <a:fillRect/>
           </a:stretch>
         </p:blipFill>
         <p:spPr>
           <a:xfrm>
-            <a:off x="6249924" y="2226564"/>
-            <a:ext cx="210312" cy="210312"/>
+            <a:off x="1023031" y="2431207"/>
+            <a:ext cx="185075" cy="185075"/>
           </a:xfrm>
           <a:prstGeom prst="rect">
             <a:avLst/>
@@ -36706,14 +36502,14 @@
       </p:pic>
       <p:sp>
         <p:nvSpPr>
-          <p:cNvPr id="17" name="Text 12"/>
+          <p:cNvPr id="13" name="Text 9"/>
           <p:cNvSpPr/>
           <p:nvPr/>
         </p:nvSpPr>
         <p:spPr>
           <a:xfrm>
-            <a:off x="6126480" y="2670048"/>
-            <a:ext cx="2514600" cy="329184"/>
+            <a:off x="1481328" y="2322576"/>
+            <a:ext cx="1920240" cy="402336"/>
           </a:xfrm>
           <a:prstGeom prst="rect">
             <a:avLst/>
@@ -36729,7 +36525,7 @@
               <a:buNone/>
             </a:pPr>
             <a:r>
-              <a:rPr lang="en-US" sz="1400" b="1" dirty="0">
+              <a:rPr lang="en-US" sz="1250" b="1" dirty="0">
                 <a:solidFill>
                   <a:srgbClr val="FFFFFF"/>
                 </a:solidFill>
@@ -36737,22 +36533,22 @@
                 <a:ea typeface="Montserrat" pitchFamily="34" charset="-122"/>
                 <a:cs typeface="Montserrat" pitchFamily="34" charset="-120"/>
               </a:rPr>
-              <a:t>Take the tools</a:t>
+              <a:t>FAQ</a:t>
             </a:r>
-            <a:endParaRPr lang="en-US" sz="1400" dirty="0"/>
+            <a:endParaRPr lang="en-US" sz="1250" dirty="0"/>
           </a:p>
         </p:txBody>
       </p:sp>
       <p:sp>
         <p:nvSpPr>
-          <p:cNvPr id="18" name="Text 13"/>
+          <p:cNvPr id="14" name="Text 10"/>
           <p:cNvSpPr/>
           <p:nvPr/>
         </p:nvSpPr>
         <p:spPr>
           <a:xfrm>
-            <a:off x="6126480" y="3054096"/>
-            <a:ext cx="2514600" cy="1005840"/>
+            <a:off x="3429000" y="2286000"/>
+            <a:ext cx="4846320" cy="475488"/>
           </a:xfrm>
           <a:prstGeom prst="rect">
             <a:avLst/>
@@ -36761,17 +36557,14 @@
           <a:ln/>
         </p:spPr>
         <p:txBody>
-          <a:bodyPr wrap="square" lIns="0" tIns="0" rIns="0" bIns="0" rtlCol="0" anchor="t"/>
+          <a:bodyPr wrap="square" lIns="0" tIns="0" rIns="0" bIns="0" rtlCol="0" anchor="ctr"/>
           <a:lstStyle/>
           <a:p>
             <a:pPr indent="0" marL="0">
-              <a:spcAft>
-                <a:spcPts val="400"/>
-              </a:spcAft>
               <a:buNone/>
             </a:pPr>
             <a:r>
-              <a:rPr lang="en-US" sz="1050" dirty="0">
+              <a:rPr lang="en-US" sz="1200" dirty="0">
                 <a:solidFill>
                   <a:srgbClr val="B9C6D6"/>
                 </a:solidFill>
@@ -36779,19 +36572,121 @@
                 <a:ea typeface="Calibri" pitchFamily="34" charset="-122"/>
                 <a:cs typeface="Calibri" pitchFamily="34" charset="-120"/>
               </a:rPr>
-              <a:t>github.com/curtismu7/ai-gateway-client</a:t>
+              <a:t>docs/FAQ.md in the repo</a:t>
             </a:r>
-            <a:endParaRPr lang="en-US" sz="1050" dirty="0"/>
+            <a:endParaRPr lang="en-US" sz="1200" dirty="0"/>
           </a:p>
+        </p:txBody>
+      </p:sp>
+      <p:sp>
+        <p:nvSpPr>
+          <p:cNvPr id="15" name="Shape 11"/>
+          <p:cNvSpPr/>
+          <p:nvPr/>
+        </p:nvSpPr>
+        <p:spPr>
+          <a:xfrm>
+            <a:off x="914400" y="2907792"/>
+            <a:ext cx="402336" cy="402336"/>
+          </a:xfrm>
+          <a:prstGeom prst="ellipse">
+            <a:avLst/>
+          </a:prstGeom>
+          <a:solidFill>
+            <a:srgbClr val="C8102E"/>
+          </a:solidFill>
+          <a:ln/>
+        </p:spPr>
+      </p:sp>
+      <p:pic>
+        <p:nvPicPr>
+          <p:cNvPr id="16" name="Image 2" descr="preencoded.png">    </p:cNvPr>
+          <p:cNvPicPr>
+            <a:picLocks noChangeAspect="1"/>
+          </p:cNvPicPr>
+          <p:nvPr/>
+        </p:nvPicPr>
+        <p:blipFill>
+          <a:blip r:embed="rId3"/>
+          <a:stretch>
+            <a:fillRect/>
+          </a:stretch>
+        </p:blipFill>
+        <p:spPr>
+          <a:xfrm>
+            <a:off x="1023031" y="3016423"/>
+            <a:ext cx="185075" cy="185075"/>
+          </a:xfrm>
+          <a:prstGeom prst="rect">
+            <a:avLst/>
+          </a:prstGeom>
+        </p:spPr>
+      </p:pic>
+      <p:sp>
+        <p:nvSpPr>
+          <p:cNvPr id="17" name="Text 12"/>
+          <p:cNvSpPr/>
+          <p:nvPr/>
+        </p:nvSpPr>
+        <p:spPr>
+          <a:xfrm>
+            <a:off x="1481328" y="2907792"/>
+            <a:ext cx="1920240" cy="402336"/>
+          </a:xfrm>
+          <a:prstGeom prst="rect">
+            <a:avLst/>
+          </a:prstGeom>
+          <a:noFill/>
+          <a:ln/>
+        </p:spPr>
+        <p:txBody>
+          <a:bodyPr wrap="square" lIns="0" tIns="0" rIns="0" bIns="0" rtlCol="0" anchor="ctr"/>
+          <a:lstStyle/>
           <a:p>
             <a:pPr indent="0" marL="0">
-              <a:spcAft>
-                <a:spcPts val="400"/>
-              </a:spcAft>
               <a:buNone/>
             </a:pPr>
             <a:r>
-              <a:rPr lang="en-US" sz="1050" dirty="0">
+              <a:rPr lang="en-US" sz="1250" b="1" dirty="0">
+                <a:solidFill>
+                  <a:srgbClr val="FFFFFF"/>
+                </a:solidFill>
+                <a:latin typeface="Montserrat" pitchFamily="34" charset="0"/>
+                <a:ea typeface="Montserrat" pitchFamily="34" charset="-122"/>
+                <a:cs typeface="Montserrat" pitchFamily="34" charset="-120"/>
+              </a:rPr>
+              <a:t>Install instructions</a:t>
+            </a:r>
+            <a:endParaRPr lang="en-US" sz="1250" dirty="0"/>
+          </a:p>
+        </p:txBody>
+      </p:sp>
+      <p:sp>
+        <p:nvSpPr>
+          <p:cNvPr id="18" name="Text 13"/>
+          <p:cNvSpPr/>
+          <p:nvPr/>
+        </p:nvSpPr>
+        <p:spPr>
+          <a:xfrm>
+            <a:off x="3429000" y="2871216"/>
+            <a:ext cx="4846320" cy="475488"/>
+          </a:xfrm>
+          <a:prstGeom prst="rect">
+            <a:avLst/>
+          </a:prstGeom>
+          <a:noFill/>
+          <a:ln/>
+        </p:spPr>
+        <p:txBody>
+          <a:bodyPr wrap="square" lIns="0" tIns="0" rIns="0" bIns="0" rtlCol="0" anchor="ctr"/>
+          <a:lstStyle/>
+          <a:p>
+            <a:pPr indent="0" marL="0">
+              <a:buNone/>
+            </a:pPr>
+            <a:r>
+              <a:rPr lang="en-US" sz="1200" dirty="0">
                 <a:solidFill>
                   <a:srgbClr val="B9C6D6"/>
                 </a:solidFill>
@@ -36799,19 +36694,121 @@
                 <a:ea typeface="Calibri" pitchFamily="34" charset="-122"/>
                 <a:cs typeface="Calibri" pitchFamily="34" charset="-120"/>
               </a:rPr>
-              <a:t>github.com/curtismu7/mcp-inspector</a:t>
+              <a:t>docs/FAQ.md, "Download and install" · docs/user-guide/getting-started.md</a:t>
             </a:r>
-            <a:endParaRPr lang="en-US" sz="1050" dirty="0"/>
+            <a:endParaRPr lang="en-US" sz="1200" dirty="0"/>
           </a:p>
+        </p:txBody>
+      </p:sp>
+      <p:sp>
+        <p:nvSpPr>
+          <p:cNvPr id="19" name="Shape 14"/>
+          <p:cNvSpPr/>
+          <p:nvPr/>
+        </p:nvSpPr>
+        <p:spPr>
+          <a:xfrm>
+            <a:off x="914400" y="3493008"/>
+            <a:ext cx="402336" cy="402336"/>
+          </a:xfrm>
+          <a:prstGeom prst="ellipse">
+            <a:avLst/>
+          </a:prstGeom>
+          <a:solidFill>
+            <a:srgbClr val="C8102E"/>
+          </a:solidFill>
+          <a:ln/>
+        </p:spPr>
+      </p:sp>
+      <p:pic>
+        <p:nvPicPr>
+          <p:cNvPr id="20" name="Image 3" descr="preencoded.png">    </p:cNvPr>
+          <p:cNvPicPr>
+            <a:picLocks noChangeAspect="1"/>
+          </p:cNvPicPr>
+          <p:nvPr/>
+        </p:nvPicPr>
+        <p:blipFill>
+          <a:blip r:embed="rId4"/>
+          <a:stretch>
+            <a:fillRect/>
+          </a:stretch>
+        </p:blipFill>
+        <p:spPr>
+          <a:xfrm>
+            <a:off x="1023031" y="3601639"/>
+            <a:ext cx="185075" cy="185075"/>
+          </a:xfrm>
+          <a:prstGeom prst="rect">
+            <a:avLst/>
+          </a:prstGeom>
+        </p:spPr>
+      </p:pic>
+      <p:sp>
+        <p:nvSpPr>
+          <p:cNvPr id="21" name="Text 15"/>
+          <p:cNvSpPr/>
+          <p:nvPr/>
+        </p:nvSpPr>
+        <p:spPr>
+          <a:xfrm>
+            <a:off x="1481328" y="3493008"/>
+            <a:ext cx="1920240" cy="402336"/>
+          </a:xfrm>
+          <a:prstGeom prst="rect">
+            <a:avLst/>
+          </a:prstGeom>
+          <a:noFill/>
+          <a:ln/>
+        </p:spPr>
+        <p:txBody>
+          <a:bodyPr wrap="square" lIns="0" tIns="0" rIns="0" bIns="0" rtlCol="0" anchor="ctr"/>
+          <a:lstStyle/>
           <a:p>
             <a:pPr indent="0" marL="0">
-              <a:spcAft>
-                <a:spcPts val="400"/>
-              </a:spcAft>
               <a:buNone/>
             </a:pPr>
             <a:r>
-              <a:rPr lang="en-US" sz="1050" dirty="0">
+              <a:rPr lang="en-US" sz="1250" b="1" dirty="0">
+                <a:solidFill>
+                  <a:srgbClr val="FFFFFF"/>
+                </a:solidFill>
+                <a:latin typeface="Montserrat" pitchFamily="34" charset="0"/>
+                <a:ea typeface="Montserrat" pitchFamily="34" charset="-122"/>
+                <a:cs typeface="Montserrat" pitchFamily="34" charset="-120"/>
+              </a:rPr>
+              <a:t>Demo guide</a:t>
+            </a:r>
+            <a:endParaRPr lang="en-US" sz="1250" dirty="0"/>
+          </a:p>
+        </p:txBody>
+      </p:sp>
+      <p:sp>
+        <p:nvSpPr>
+          <p:cNvPr id="22" name="Text 16"/>
+          <p:cNvSpPr/>
+          <p:nvPr/>
+        </p:nvSpPr>
+        <p:spPr>
+          <a:xfrm>
+            <a:off x="3429000" y="3456432"/>
+            <a:ext cx="4846320" cy="475488"/>
+          </a:xfrm>
+          <a:prstGeom prst="rect">
+            <a:avLst/>
+          </a:prstGeom>
+          <a:noFill/>
+          <a:ln/>
+        </p:spPr>
+        <p:txBody>
+          <a:bodyPr wrap="square" lIns="0" tIns="0" rIns="0" bIns="0" rtlCol="0" anchor="ctr"/>
+          <a:lstStyle/>
+          <a:p>
+            <a:pPr indent="0" marL="0">
+              <a:buNone/>
+            </a:pPr>
+            <a:r>
+              <a:rPr lang="en-US" sz="1200" dirty="0">
                 <a:solidFill>
                   <a:srgbClr val="B9C6D6"/>
                 </a:solidFill>
@@ -36819,9 +36816,79 @@
                 <a:ea typeface="Calibri" pitchFamily="34" charset="-122"/>
                 <a:cs typeface="Calibri" pitchFamily="34" charset="-120"/>
               </a:rPr>
-              <a:t>github.com/curtismu7/llm-gateway</a:t>
+              <a:t>In the app: /demo-track (Guided Demo Track)</a:t>
             </a:r>
-            <a:endParaRPr lang="en-US" sz="1050" dirty="0"/>
+            <a:endParaRPr lang="en-US" sz="1200" dirty="0"/>
+          </a:p>
+          <a:p>
+            <a:pPr indent="0" marL="0">
+              <a:buNone/>
+            </a:pPr>
+            <a:r>
+              <a:rPr lang="en-US" sz="1200" dirty="0">
+                <a:solidFill>
+                  <a:srgbClr val="B9C6D6"/>
+                </a:solidFill>
+                <a:latin typeface="Calibri" pitchFamily="34" charset="0"/>
+                <a:ea typeface="Calibri" pitchFamily="34" charset="-122"/>
+                <a:cs typeface="Calibri" pitchFamily="34" charset="-120"/>
+              </a:rPr>
+              <a:t>docs/user-guide/AGENT_SHOWCASE_DEMO_SCENARIOS.md</a:t>
+            </a:r>
+            <a:endParaRPr lang="en-US" sz="1200" dirty="0"/>
+          </a:p>
+        </p:txBody>
+      </p:sp>
+      <p:sp>
+        <p:nvSpPr>
+          <p:cNvPr id="23" name="Text 17"/>
+          <p:cNvSpPr/>
+          <p:nvPr/>
+        </p:nvSpPr>
+        <p:spPr>
+          <a:xfrm>
+            <a:off x="914400" y="4114800"/>
+            <a:ext cx="7315200" cy="292608"/>
+          </a:xfrm>
+          <a:prstGeom prst="rect">
+            <a:avLst/>
+          </a:prstGeom>
+          <a:noFill/>
+          <a:ln/>
+        </p:spPr>
+        <p:txBody>
+          <a:bodyPr wrap="square" lIns="0" tIns="0" rIns="0" bIns="0" rtlCol="0" anchor="ctr"/>
+          <a:lstStyle/>
+          <a:p>
+            <a:pPr indent="0" marL="0">
+              <a:buNone/>
+            </a:pPr>
+            <a:r>
+              <a:rPr lang="en-US" sz="1100" b="1" dirty="0">
+                <a:solidFill>
+                  <a:srgbClr val="FFFFFF"/>
+                </a:solidFill>
+                <a:latin typeface="Calibri" pitchFamily="34" charset="0"/>
+                <a:ea typeface="Calibri" pitchFamily="34" charset="-122"/>
+                <a:cs typeface="Calibri" pitchFamily="34" charset="-120"/>
+              </a:rPr>
+              <a:t>Take the tools:  </a:t>
+            </a:r>
+            <a:pPr indent="0" marL="0">
+              <a:buNone/>
+            </a:pPr>
+            <a:r>
+              <a:rPr lang="en-US" sz="1100" dirty="0">
+                <a:solidFill>
+                  <a:srgbClr val="B9C6D6"/>
+                </a:solidFill>
+                <a:latin typeface="Calibri" pitchFamily="34" charset="0"/>
+                <a:ea typeface="Calibri" pitchFamily="34" charset="-122"/>
+                <a:cs typeface="Calibri" pitchFamily="34" charset="-120"/>
+              </a:rPr>
+              <a:t>github.com/curtismu7/ai-gateway-client · mcp-inspector · llm-gateway</a:t>
+            </a:r>
+            <a:endParaRPr lang="en-US" sz="1100" dirty="0"/>
           </a:p>
         </p:txBody>
       </p:sp>

</xml_diff>

<commit_message>
docs+chore: finish AI Gateway → Agent Privilege rename in docs and services
Sweeps the remaining user-facing occurrences outside demo_api_ui/src and
demo_api_server (already renamed in 747b2ad12 / 78f7bdab0): privilege/
setup docs, docs/ guides and mockups, standalone clients, demo_mcp_*
services, scripts, k8s/docker-compose, helm homepage, REGRESSION_PLAN,
TECH_DEBT, and the AI-Demo-Overview.pptx deck (12 text runs across 5
slides + 5 speaker notes, repacked with the pptx skill).

Internal identifiers keep the old name on purpose: privilege-ai-gateway
flow key, ff_mcp_gateway_privilege_first flag, /ai-gateway/* routes,
standalone/ai-gateway-client directory.

Co-Authored-By: Claude Code <noreply@anthropic.com>
</commit_message>
<xml_diff>
--- a/docs/resources/AI-Demo-Overview.pptx
+++ b/docs/resources/AI-Demo-Overview.pptx
@@ -615,7 +615,7 @@
               <a:t>Simulator: demo_api_server/services/attackSimulatorService.js (sim IDs mapped to use cases at lines 54-65), run via POST /api/demo/attack-sim/run (routes/attackSimulator.js). The route returns 403 when NODE_ENV=production or ff_use_cases_launcher is false, and always answers HTTP 200 with the sim's real status in the body.
 Only rogue-actor (UC13) and cross-owner-account (UC10) run the full BFF pipeline; the others probe the gateway perimeter. UC5 and UC18 always target the Node Demo Agent Gateway, even when PingGateway is active, so they need that container up.
 Caveats: UC12 tests audience binding only, never DPoP, even though its flag is ff_dpop. UC14 needs ff_rar. UC16 returns 403 by design while the catalog still expects 401. The simulator leaves ff_mcp_rate_limit and ff_rar switched on afterwards.
-AI layer: the BFF prompt guard (services/promptGuard.js, promptSanitizer.js, 7 regexes, default on) is keyword-based and easy to phrase around. The Privilege AI Gateway is the stronger layer: prompt injection and jailbreak return HTTP 400; PII and exfiltration are redacted in a 200. Malicious content, tool abuse, tool poisoning, schema violation and inter-agent abuse presets get no verdict there (demo_api_ui/src/config/guardrailAttackCatalog.js). The ML promptguard sidecar runs only in the SE cluster.
+AI layer: the BFF prompt guard (services/promptGuard.js, promptSanitizer.js, 7 regexes, default on) is keyword-based and easy to phrase around. The Agent Privilege is the stronger layer: prompt injection and jailbreak return HTTP 400; PII and exfiltration are redacted in a 200. Malicious content, tool abuse, tool poisoning, schema violation and inter-agent abuse presets get no verdict there (demo_api_ui/src/config/guardrailAttackCatalog.js). The ML promptguard sidecar runs only in the SE cluster.
 Red team, nothing blocks: argument-level tool poisoning (only the normal 428 approval gate, confirmed live on 2026-09-13 with nothing flagging the injected text; approving executes it, toolAttackCatalog.js), the hostile MCP server (standalone/hostile-mcp-server, deliberately not behind the gateway), and the ungoverned OpenCLI agent (UC-LEARN7, compose profile demo-attack). Present these as the contrast, not as blocked.
 Framework mapping: every use case carries OWASP Agentic (ASI) threat tags; see OwaspLearnerPage.js. MITRE ATLAS and NIST labels appear only in Privilege's own verdict log.</a:t>
             </a:r>
@@ -806,7 +806,7 @@
             <a:r>
               <a:rPr lang="en-US" dirty="0"/>
               <a:t>Tool registries: oauth-mcp/src/tools/BankingToolRegistry.ts; demo_mcp_resource_server/src/tools/*Tools.ts; demo_mcp_gateway/src/router.ts (weather, Brave, audit). mcp-tool-schemas.json is the generated union of 252 tools (copy in ping-gateway/config/).
-Gateways: PingGateway is the default (host :3036). Its main routes introspect tokens; the *-jwks.json twins are used when a request sends X-Token-Validation: jwks. Every route runs request validation, audit and the P1AZ decision script. The Node gateway (:3005, demo-auth group) validates with JWKS only. The Privilege AI Gateway runs as Agentic Apps on the SE cluster (local ping-mcpgw is the opt-in mcpgw group).
+Gateways: PingGateway is the default (host :3036). Its main routes introspect tokens; the *-jwks.json twins are used when a request sends X-Token-Validation: jwks. Every route runs request validation, audit and the P1AZ decision script. The Node gateway (:3005, demo-auth group) validates with JWKS only. The Agent Privilege runs as Agentic Apps on the SE cluster (local ping-mcpgw is the opt-in mcpgw group).
 Transports: oauth-mcp speaks WebSocket and Streamable HTTP /mcp; Brave, Grafana and the PingOne bridge also answer the SSE handshake Privilege uses for discovery; weather and the PingOne bridge wrap stdio-only upstreams. MCP_MTLS_ON is unset in the root .env, so the gateway to oauth-mcp hop is plaintext.
 Start-up: oauth-mcp, resource server, weather, Brave and the MCP proxy are core; code search is the rag group (on by default) and is plain REST, not MCP; jwt-verifier is demo-auth; opensearch is mcpgw; the hostile server runs with npm start, outside compose. mcp-audit has no compose profile but isn't in run-docker.sh's core list.
 Also: the BFF MCP facade (:3002, routes/mcpFacade.js) is a recording proxy with doors for outside clients such as LM Studio and LibreChat. demo_mcp_proxy (:8895) turns REST calls into MCP calls for simple agents.
@@ -1361,7 +1361,7 @@
 Two traps:
 - The live environment has no dedicated 'Demo AI App - CIBA' app, so CIBA falls back to the Admin Login app.
 - Management API calls try PINGONE_MGMT_* and PINGONE_MANAGEMENT_* first, then the Admin Login app, and only then the worker (services/configStore.js). A Management API failure can therefore be the Admin Login app.
-Privilege AI Gateway sign-in uses a client in the Privilege tenant (0428ba4f), not this environment; its secret lives in the vault.</a:t>
+Agent Privilege sign-in uses a client in the Privilege tenant (0428ba4f), not this environment; its secret lives in the vault.</a:t>
             </a:r>
             <a:endParaRPr lang="en-US" dirty="0"/>
           </a:p>
@@ -2389,7 +2389,7 @@
 - Gateway default is PingGateway; the Node gateway (demo_mcp_gateway, :3005) is the opt-in alternative.
 - Authorize answers PERMIT, DENY or INDETERMINATE; INDETERMINATE from the demo engine means pause for consent or step-up.
 - MCP servers re-check audience and scope as the last line. The mortgage backend takes an API key instead.
-- Optional: the PingOne Privilege AI Gateway can sit in front of the Agent Gateway (ff_mcp_gateway_privilege_first, SE cluster only).</a:t>
+- Optional: the PingOne Agent Privilege can sit in front of the Agent Gateway (ff_mcp_gateway_privilege_first, SE cluster only).</a:t>
             </a:r>
             <a:endParaRPr lang="en-US" dirty="0"/>
           </a:p>
@@ -2477,7 +2477,7 @@
           <a:p>
             <a:r>
               <a:rPr lang="en-US" dirty="0"/>
-              <a:t>Where it runs: one agentless AI Gateway (Helm release agentless-mcpgw, namespace ping-devops-curtismuir) on the Ping SE cluster, in PingOne tenant 0428ba4f, federated into the demo tenant. MCP doors: https://mcpgw.ai-demo.ping-devops.com/&lt;App&gt;/mcp; LLM lanes /llm/{openai,anthropic,google}/v1 on the same host (privilege/CURRENT-CONFIGURATION.md).
+              <a:t>Where it runs: one agentless Agent Privilege (Helm release agentless-mcpgw, namespace ping-devops-curtismuir) on the Ping SE cluster, in PingOne tenant 0428ba4f, federated into the demo tenant. MCP doors: https://mcpgw.ai-demo.ping-devops.com/&lt;App&gt;/mcp; LLM lanes /llm/{openai,anthropic,google}/v1 on the same host (privilege/CURRENT-CONFIGURATION.md).
 MCP gateway: a JSON-RPC POST gets a 401 pointing at RFC 9728 metadata; the client registers (POST /&lt;app&gt;/register) and runs PKCE. The gateway keeps registrations in memory, so a restart forgets them; the BFF re-registers via isDcrClientStillKnown (routes/privilegeMcpClient.js). Doors on /privilege-mcp-client: Direct (no Privilege), Privilege (policy enforced), Facade (same policy, client registered with the demo's own auth server).
 Policy traps (privilege/LESSONS-LEARNED.md): policies union, so delete extras instead of editing; a new app denies everything; an expired policy looks like a missing one; clients only see a bare 403.
 Privilege first: ff_mcp_gateway_privilege_first puts Privilege in front of the Agent Gateway, with the user token in X-Subject-Token (services/mcpGatewayTransport.js). ff_privilege_llm_first sends google and anthropic calls through Privilege virtual keys (services/llmProviderResolver.js, privilegeLlmProxyService.js).
@@ -9518,7 +9518,7 @@
                 <a:ea typeface="Calibri" pitchFamily="34" charset="-122"/>
                 <a:cs typeface="Calibri" pitchFamily="34" charset="-120"/>
               </a:rPr>
-              <a:t>Not in the app:  </a:t>
+              <a:t xml:space="preserve">Not in the app:  </a:t>
             </a:r>
             <a:pPr indent="0" marL="0">
               <a:buNone/>
@@ -11875,7 +11875,7 @@
                           <a:ea typeface="Calibri" pitchFamily="34" charset="-122"/>
                           <a:cs typeface="Calibri" pitchFamily="34" charset="-120"/>
                         </a:rPr>
-                        <a:t>Privilege AI Gateway</a:t>
+                        <a:t>Agent Privilege</a:t>
                       </a:r>
                       <a:endParaRPr lang="en-US" sz="950" dirty="0">
                         <a:latin typeface="Calibri" charset="0"/>
@@ -12149,7 +12149,7 @@
                           <a:ea typeface="Calibri" pitchFamily="34" charset="-122"/>
                           <a:cs typeface="Calibri" pitchFamily="34" charset="-120"/>
                         </a:rPr>
-                        <a:t>Privilege AI Gateway (SE)</a:t>
+                        <a:t>Agent Privilege (SE)</a:t>
                       </a:r>
                       <a:endParaRPr lang="en-US" sz="950" dirty="0">
                         <a:latin typeface="Calibri" charset="0"/>
@@ -12811,7 +12811,7 @@
                 <a:ea typeface="Calibri" pitchFamily="34" charset="-122"/>
                 <a:cs typeface="Calibri" pitchFamily="34" charset="-120"/>
               </a:rPr>
-              <a:t>Front doors:  </a:t>
+              <a:t xml:space="preserve">Front doors:  </a:t>
             </a:r>
             <a:pPr indent="0" marL="0">
               <a:buNone/>
@@ -12825,7 +12825,7 @@
                 <a:ea typeface="Calibri" pitchFamily="34" charset="-122"/>
                 <a:cs typeface="Calibri" pitchFamily="34" charset="-120"/>
               </a:rPr>
-              <a:t>PingGateway (default) · Node gateway (opt-in) · Privilege AI Gateway (SE) · BFF facade for outside MCP clients</a:t>
+              <a:t>PingGateway (default) · Node gateway (opt-in) · Agent Privilege (SE) · BFF facade for outside MCP clients</a:t>
             </a:r>
             <a:endParaRPr lang="en-US" sz="1050" dirty="0"/>
           </a:p>
@@ -13047,7 +13047,7 @@
       </p:sp>
       <p:pic>
         <p:nvPicPr>
-          <p:cNvPr id="9" name="Image 0" descr="preencoded.png">    </p:cNvPr>
+          <p:cNvPr id="9" name="Image 0" descr="preencoded.png"/>
           <p:cNvPicPr>
             <a:picLocks noChangeAspect="1"/>
           </p:cNvPicPr>
@@ -13363,7 +13363,7 @@
       </p:sp>
       <p:pic>
         <p:nvPicPr>
-          <p:cNvPr id="18" name="Image 1" descr="preencoded.png">    </p:cNvPr>
+          <p:cNvPr id="18" name="Image 1" descr="preencoded.png"/>
           <p:cNvPicPr>
             <a:picLocks noChangeAspect="1"/>
           </p:cNvPicPr>
@@ -13679,7 +13679,7 @@
       </p:sp>
       <p:pic>
         <p:nvPicPr>
-          <p:cNvPr id="27" name="Image 2" descr="preencoded.png">    </p:cNvPr>
+          <p:cNvPr id="27" name="Image 2" descr="preencoded.png"/>
           <p:cNvPicPr>
             <a:picLocks noChangeAspect="1"/>
           </p:cNvPicPr>
@@ -14006,7 +14006,7 @@
                 <a:ea typeface="Calibri" pitchFamily="34" charset="-122"/>
                 <a:cs typeface="Calibri" pitchFamily="34" charset="-120"/>
               </a:rPr>
-              <a:t>Also:  </a:t>
+              <a:t xml:space="preserve">Also:  </a:t>
             </a:r>
             <a:pPr indent="0" marL="0">
               <a:buNone/>
@@ -14242,7 +14242,7 @@
       </p:sp>
       <p:pic>
         <p:nvPicPr>
-          <p:cNvPr id="9" name="Image 0" descr="preencoded.png">    </p:cNvPr>
+          <p:cNvPr id="9" name="Image 0" descr="preencoded.png"/>
           <p:cNvPicPr>
             <a:picLocks noChangeAspect="1"/>
           </p:cNvPicPr>
@@ -14497,7 +14497,7 @@
       </p:sp>
       <p:pic>
         <p:nvPicPr>
-          <p:cNvPr id="16" name="Image 1" descr="preencoded.png">    </p:cNvPr>
+          <p:cNvPr id="16" name="Image 1" descr="preencoded.png"/>
           <p:cNvPicPr>
             <a:picLocks noChangeAspect="1"/>
           </p:cNvPicPr>
@@ -14752,7 +14752,7 @@
       </p:sp>
       <p:pic>
         <p:nvPicPr>
-          <p:cNvPr id="23" name="Image 2" descr="preencoded.png">    </p:cNvPr>
+          <p:cNvPr id="23" name="Image 2" descr="preencoded.png"/>
           <p:cNvPicPr>
             <a:picLocks noChangeAspect="1"/>
           </p:cNvPicPr>
@@ -15007,7 +15007,7 @@
       </p:sp>
       <p:pic>
         <p:nvPicPr>
-          <p:cNvPr id="30" name="Image 3" descr="preencoded.png">    </p:cNvPr>
+          <p:cNvPr id="30" name="Image 3" descr="preencoded.png"/>
           <p:cNvPicPr>
             <a:picLocks noChangeAspect="1"/>
           </p:cNvPicPr>
@@ -15262,7 +15262,7 @@
       </p:sp>
       <p:pic>
         <p:nvPicPr>
-          <p:cNvPr id="37" name="Image 4" descr="preencoded.png">    </p:cNvPr>
+          <p:cNvPr id="37" name="Image 4" descr="preencoded.png"/>
           <p:cNvPicPr>
             <a:picLocks noChangeAspect="1"/>
           </p:cNvPicPr>
@@ -15517,7 +15517,7 @@
       </p:sp>
       <p:pic>
         <p:nvPicPr>
-          <p:cNvPr id="44" name="Image 5" descr="preencoded.png">    </p:cNvPr>
+          <p:cNvPr id="44" name="Image 5" descr="preencoded.png"/>
           <p:cNvPicPr>
             <a:picLocks noChangeAspect="1"/>
           </p:cNvPicPr>
@@ -30263,7 +30263,7 @@
       </p:sp>
       <p:pic>
         <p:nvPicPr>
-          <p:cNvPr id="21" name="Image 0" descr="preencoded.png">    </p:cNvPr>
+          <p:cNvPr id="21" name="Image 0" descr="preencoded.png"/>
           <p:cNvPicPr>
             <a:picLocks noChangeAspect="1"/>
           </p:cNvPicPr>
@@ -30385,7 +30385,7 @@
       </p:sp>
       <p:pic>
         <p:nvPicPr>
-          <p:cNvPr id="25" name="Image 1" descr="preencoded.png">    </p:cNvPr>
+          <p:cNvPr id="25" name="Image 1" descr="preencoded.png"/>
           <p:cNvPicPr>
             <a:picLocks noChangeAspect="1"/>
           </p:cNvPicPr>
@@ -36356,7 +36356,7 @@
       </p:sp>
       <p:pic>
         <p:nvPicPr>
-          <p:cNvPr id="8" name="Image 0" descr="preencoded.png">    </p:cNvPr>
+          <p:cNvPr id="8" name="Image 0" descr="preencoded.png"/>
           <p:cNvPicPr>
             <a:picLocks noChangeAspect="1"/>
           </p:cNvPicPr>
@@ -36478,7 +36478,7 @@
       </p:sp>
       <p:pic>
         <p:nvPicPr>
-          <p:cNvPr id="12" name="Image 1" descr="preencoded.png">    </p:cNvPr>
+          <p:cNvPr id="12" name="Image 1" descr="preencoded.png"/>
           <p:cNvPicPr>
             <a:picLocks noChangeAspect="1"/>
           </p:cNvPicPr>
@@ -36600,7 +36600,7 @@
       </p:sp>
       <p:pic>
         <p:nvPicPr>
-          <p:cNvPr id="16" name="Image 2" descr="preencoded.png">    </p:cNvPr>
+          <p:cNvPr id="16" name="Image 2" descr="preencoded.png"/>
           <p:cNvPicPr>
             <a:picLocks noChangeAspect="1"/>
           </p:cNvPicPr>
@@ -36722,7 +36722,7 @@
       </p:sp>
       <p:pic>
         <p:nvPicPr>
-          <p:cNvPr id="20" name="Image 3" descr="preencoded.png">    </p:cNvPr>
+          <p:cNvPr id="20" name="Image 3" descr="preencoded.png"/>
           <p:cNvPicPr>
             <a:picLocks noChangeAspect="1"/>
           </p:cNvPicPr>
@@ -36872,7 +36872,7 @@
                 <a:ea typeface="Calibri" pitchFamily="34" charset="-122"/>
                 <a:cs typeface="Calibri" pitchFamily="34" charset="-120"/>
               </a:rPr>
-              <a:t>Take the tools:  </a:t>
+              <a:t xml:space="preserve">Take the tools:  </a:t>
             </a:r>
             <a:pPr indent="0" marL="0">
               <a:buNone/>
@@ -37108,7 +37108,7 @@
       </p:sp>
       <p:pic>
         <p:nvPicPr>
-          <p:cNvPr id="9" name="Image 0" descr="preencoded.png">    </p:cNvPr>
+          <p:cNvPr id="9" name="Image 0" descr="preencoded.png"/>
           <p:cNvPicPr>
             <a:picLocks noChangeAspect="1"/>
           </p:cNvPicPr>
@@ -37216,7 +37216,7 @@
                 <a:ea typeface="Calibri" pitchFamily="34" charset="-122"/>
                 <a:cs typeface="Calibri" pitchFamily="34" charset="-120"/>
               </a:rPr>
-              <a:t>  :4000</a:t>
+              <a:t xml:space="preserve">  :4000</a:t>
             </a:r>
             <a:endParaRPr lang="en-US" sz="1050" dirty="0"/>
           </a:p>
@@ -37308,7 +37308,7 @@
                 <a:ea typeface="Calibri" pitchFamily="34" charset="-122"/>
                 <a:cs typeface="Calibri" pitchFamily="34" charset="-120"/>
               </a:rPr>
-              <a:t>  :3001</a:t>
+              <a:t xml:space="preserve">  :3001</a:t>
             </a:r>
             <a:endParaRPr lang="en-US" sz="1050" dirty="0"/>
           </a:p>
@@ -37400,7 +37400,7 @@
       </p:sp>
       <p:pic>
         <p:nvPicPr>
-          <p:cNvPr id="17" name="Image 1" descr="preencoded.png">    </p:cNvPr>
+          <p:cNvPr id="17" name="Image 1" descr="preencoded.png"/>
           <p:cNvPicPr>
             <a:picLocks noChangeAspect="1"/>
           </p:cNvPicPr>
@@ -37508,7 +37508,7 @@
                 <a:ea typeface="Calibri" pitchFamily="34" charset="-122"/>
                 <a:cs typeface="Calibri" pitchFamily="34" charset="-120"/>
               </a:rPr>
-              <a:t>  :3036</a:t>
+              <a:t xml:space="preserve">  :3036</a:t>
             </a:r>
             <a:endParaRPr lang="en-US" sz="1050" dirty="0"/>
           </a:p>
@@ -37600,7 +37600,7 @@
                 <a:ea typeface="Calibri" pitchFamily="34" charset="-122"/>
                 <a:cs typeface="Calibri" pitchFamily="34" charset="-120"/>
               </a:rPr>
-              <a:t>  cloud</a:t>
+              <a:t xml:space="preserve">  cloud</a:t>
             </a:r>
             <a:endParaRPr lang="en-US" sz="1050" dirty="0"/>
           </a:p>
@@ -37692,7 +37692,7 @@
                 <a:ea typeface="Calibri" pitchFamily="34" charset="-122"/>
                 <a:cs typeface="Calibri" pitchFamily="34" charset="-120"/>
               </a:rPr>
-              <a:t>  :3009</a:t>
+              <a:t xml:space="preserve">  :3009</a:t>
             </a:r>
             <a:endParaRPr lang="en-US" sz="1050" dirty="0"/>
           </a:p>
@@ -37784,7 +37784,7 @@
                 <a:ea typeface="Calibri" pitchFamily="34" charset="-122"/>
                 <a:cs typeface="Calibri" pitchFamily="34" charset="-120"/>
               </a:rPr>
-              <a:t>  :3005</a:t>
+              <a:t xml:space="preserve">  :3005</a:t>
             </a:r>
             <a:endParaRPr lang="en-US" sz="1050" dirty="0"/>
           </a:p>
@@ -37876,7 +37876,7 @@
                 <a:ea typeface="Calibri" pitchFamily="34" charset="-122"/>
                 <a:cs typeface="Calibri" pitchFamily="34" charset="-120"/>
               </a:rPr>
-              <a:t>  :9001</a:t>
+              <a:t xml:space="preserve">  :9001</a:t>
             </a:r>
             <a:endParaRPr lang="en-US" sz="1050" dirty="0"/>
           </a:p>
@@ -37968,7 +37968,7 @@
       </p:sp>
       <p:pic>
         <p:nvPicPr>
-          <p:cNvPr id="31" name="Image 2" descr="preencoded.png">    </p:cNvPr>
+          <p:cNvPr id="31" name="Image 2" descr="preencoded.png"/>
           <p:cNvPicPr>
             <a:picLocks noChangeAspect="1"/>
           </p:cNvPicPr>
@@ -38076,7 +38076,7 @@
                 <a:ea typeface="Calibri" pitchFamily="34" charset="-122"/>
                 <a:cs typeface="Calibri" pitchFamily="34" charset="-120"/>
               </a:rPr>
-              <a:t>  :8080</a:t>
+              <a:t xml:space="preserve">  :8080</a:t>
             </a:r>
             <a:endParaRPr lang="en-US" sz="1050" dirty="0"/>
           </a:p>
@@ -38168,7 +38168,7 @@
                 <a:ea typeface="Calibri" pitchFamily="34" charset="-122"/>
                 <a:cs typeface="Calibri" pitchFamily="34" charset="-120"/>
               </a:rPr>
-              <a:t>  :8081</a:t>
+              <a:t xml:space="preserve">  :8081</a:t>
             </a:r>
             <a:endParaRPr lang="en-US" sz="1050" dirty="0"/>
           </a:p>
@@ -38260,7 +38260,7 @@
                 <a:ea typeface="Calibri" pitchFamily="34" charset="-122"/>
                 <a:cs typeface="Calibri" pitchFamily="34" charset="-120"/>
               </a:rPr>
-              <a:t>  :8082</a:t>
+              <a:t xml:space="preserve">  :8082</a:t>
             </a:r>
             <a:endParaRPr lang="en-US" sz="1050" dirty="0"/>
           </a:p>
@@ -38352,7 +38352,7 @@
                 <a:ea typeface="Calibri" pitchFamily="34" charset="-122"/>
                 <a:cs typeface="Calibri" pitchFamily="34" charset="-120"/>
               </a:rPr>
-              <a:t>  :8896/7</a:t>
+              <a:t xml:space="preserve">  :8896/7</a:t>
             </a:r>
             <a:endParaRPr lang="en-US" sz="1050" dirty="0"/>
           </a:p>
@@ -38444,7 +38444,7 @@
                 <a:ea typeface="Calibri" pitchFamily="34" charset="-122"/>
                 <a:cs typeface="Calibri" pitchFamily="34" charset="-120"/>
               </a:rPr>
-              <a:t>  :8895</a:t>
+              <a:t xml:space="preserve">  :8895</a:t>
             </a:r>
             <a:endParaRPr lang="en-US" sz="1050" dirty="0"/>
           </a:p>
@@ -38536,7 +38536,7 @@
       </p:sp>
       <p:pic>
         <p:nvPicPr>
-          <p:cNvPr id="45" name="Image 3" descr="preencoded.png">    </p:cNvPr>
+          <p:cNvPr id="45" name="Image 3" descr="preencoded.png"/>
           <p:cNvPicPr>
             <a:picLocks noChangeAspect="1"/>
           </p:cNvPicPr>
@@ -38644,7 +38644,7 @@
                 <a:ea typeface="Calibri" pitchFamily="34" charset="-122"/>
                 <a:cs typeface="Calibri" pitchFamily="34" charset="-120"/>
               </a:rPr>
-              <a:t>  :3016</a:t>
+              <a:t xml:space="preserve">  :3016</a:t>
             </a:r>
             <a:endParaRPr lang="en-US" sz="1050" dirty="0"/>
           </a:p>
@@ -38736,7 +38736,7 @@
                 <a:ea typeface="Calibri" pitchFamily="34" charset="-122"/>
                 <a:cs typeface="Calibri" pitchFamily="34" charset="-120"/>
               </a:rPr>
-              <a:t>  :8888</a:t>
+              <a:t xml:space="preserve">  :8888</a:t>
             </a:r>
             <a:endParaRPr lang="en-US" sz="1050" dirty="0"/>
           </a:p>
@@ -38828,7 +38828,7 @@
                 <a:ea typeface="Calibri" pitchFamily="34" charset="-122"/>
                 <a:cs typeface="Calibri" pitchFamily="34" charset="-120"/>
               </a:rPr>
-              <a:t>  :8090</a:t>
+              <a:t xml:space="preserve">  :8090</a:t>
             </a:r>
             <a:endParaRPr lang="en-US" sz="1050" dirty="0"/>
           </a:p>
@@ -38920,7 +38920,7 @@
                 <a:ea typeface="Calibri" pitchFamily="34" charset="-122"/>
                 <a:cs typeface="Calibri" pitchFamily="34" charset="-120"/>
               </a:rPr>
-              <a:t>  :8095</a:t>
+              <a:t xml:space="preserve">  :8095</a:t>
             </a:r>
             <a:endParaRPr lang="en-US" sz="1050" dirty="0"/>
           </a:p>
@@ -39023,7 +39023,7 @@
                 <a:ea typeface="Calibri" pitchFamily="34" charset="-122"/>
                 <a:cs typeface="Calibri" pitchFamily="34" charset="-120"/>
               </a:rPr>
-              <a:t>Hosted by Ping:  </a:t>
+              <a:t xml:space="preserve">Hosted by Ping:  </a:t>
             </a:r>
             <a:pPr indent="0" marL="0">
               <a:buNone/>
@@ -39051,7 +39051,7 @@
                 <a:ea typeface="Calibri" pitchFamily="34" charset="-122"/>
                 <a:cs typeface="Calibri" pitchFamily="34" charset="-120"/>
               </a:rPr>
-              <a:t>          Opt-in:  </a:t>
+              <a:t xml:space="preserve">          Opt-in:  </a:t>
             </a:r>
             <a:pPr indent="0" marL="0">
               <a:buNone/>
@@ -40109,7 +40109,7 @@
                           <a:ea typeface="Calibri" pitchFamily="34" charset="-122"/>
                           <a:cs typeface="Calibri" pitchFamily="34" charset="-120"/>
                         </a:rPr>
-                        <a:t>AI Gateway Client</a:t>
+                        <a:t>Agent Privilege Client</a:t>
                       </a:r>
                       <a:endParaRPr lang="en-US" sz="1050" dirty="0">
                         <a:latin typeface="Calibri" charset="0"/>
@@ -41341,7 +41341,7 @@
       </p:sp>
       <p:pic>
         <p:nvPicPr>
-          <p:cNvPr id="9" name="Image 0" descr="preencoded.png">    </p:cNvPr>
+          <p:cNvPr id="9" name="Image 0" descr="preencoded.png"/>
           <p:cNvPicPr>
             <a:picLocks noChangeAspect="1"/>
           </p:cNvPicPr>
@@ -41589,7 +41589,7 @@
       </p:sp>
       <p:pic>
         <p:nvPicPr>
-          <p:cNvPr id="17" name="Image 1" descr="preencoded.png">    </p:cNvPr>
+          <p:cNvPr id="17" name="Image 1" descr="preencoded.png"/>
           <p:cNvPicPr>
             <a:picLocks noChangeAspect="1"/>
           </p:cNvPicPr>
@@ -41837,7 +41837,7 @@
       </p:sp>
       <p:pic>
         <p:nvPicPr>
-          <p:cNvPr id="25" name="Image 2" descr="preencoded.png">    </p:cNvPr>
+          <p:cNvPr id="25" name="Image 2" descr="preencoded.png"/>
           <p:cNvPicPr>
             <a:picLocks noChangeAspect="1"/>
           </p:cNvPicPr>
@@ -42085,7 +42085,7 @@
       </p:sp>
       <p:pic>
         <p:nvPicPr>
-          <p:cNvPr id="33" name="Image 3" descr="preencoded.png">    </p:cNvPr>
+          <p:cNvPr id="33" name="Image 3" descr="preencoded.png"/>
           <p:cNvPicPr>
             <a:picLocks noChangeAspect="1"/>
           </p:cNvPicPr>
@@ -42333,7 +42333,7 @@
       </p:sp>
       <p:pic>
         <p:nvPicPr>
-          <p:cNvPr id="41" name="Image 4" descr="preencoded.png">    </p:cNvPr>
+          <p:cNvPr id="41" name="Image 4" descr="preencoded.png"/>
           <p:cNvPicPr>
             <a:picLocks noChangeAspect="1"/>
           </p:cNvPicPr>
@@ -42581,7 +42581,7 @@
       </p:sp>
       <p:pic>
         <p:nvPicPr>
-          <p:cNvPr id="49" name="Image 5" descr="preencoded.png">    </p:cNvPr>
+          <p:cNvPr id="49" name="Image 5" descr="preencoded.png"/>
           <p:cNvPicPr>
             <a:picLocks noChangeAspect="1"/>
           </p:cNvPicPr>
@@ -42973,7 +42973,7 @@
       </p:sp>
       <p:pic>
         <p:nvPicPr>
-          <p:cNvPr id="8" name="Image 0" descr="preencoded.png">    </p:cNvPr>
+          <p:cNvPr id="8" name="Image 0" descr="preencoded.png"/>
           <p:cNvPicPr>
             <a:picLocks noChangeAspect="1"/>
           </p:cNvPicPr>
@@ -43042,7 +43042,7 @@
                 <a:ea typeface="Calibri" pitchFamily="34" charset="-122"/>
                 <a:cs typeface="Calibri" pitchFamily="34" charset="-120"/>
               </a:rPr>
-              <a:t>   UC1 · UC33 · UC34</a:t>
+              <a:t xml:space="preserve">   UC1 · UC33 · UC34</a:t>
             </a:r>
             <a:endParaRPr lang="en-US" sz="1100" dirty="0"/>
           </a:p>
@@ -43109,7 +43109,7 @@
       </p:sp>
       <p:pic>
         <p:nvPicPr>
-          <p:cNvPr id="12" name="Image 1" descr="preencoded.png">    </p:cNvPr>
+          <p:cNvPr id="12" name="Image 1" descr="preencoded.png"/>
           <p:cNvPicPr>
             <a:picLocks noChangeAspect="1"/>
           </p:cNvPicPr>
@@ -43178,7 +43178,7 @@
                 <a:ea typeface="Calibri" pitchFamily="34" charset="-122"/>
                 <a:cs typeface="Calibri" pitchFamily="34" charset="-120"/>
               </a:rPr>
-              <a:t>   UC8 · UC23 · UC27</a:t>
+              <a:t xml:space="preserve">   UC8 · UC23 · UC27</a:t>
             </a:r>
             <a:endParaRPr lang="en-US" sz="1100" dirty="0"/>
           </a:p>
@@ -43245,7 +43245,7 @@
       </p:sp>
       <p:pic>
         <p:nvPicPr>
-          <p:cNvPr id="16" name="Image 2" descr="preencoded.png">    </p:cNvPr>
+          <p:cNvPr id="16" name="Image 2" descr="preencoded.png"/>
           <p:cNvPicPr>
             <a:picLocks noChangeAspect="1"/>
           </p:cNvPicPr>
@@ -43314,7 +43314,7 @@
                 <a:ea typeface="Calibri" pitchFamily="34" charset="-122"/>
                 <a:cs typeface="Calibri" pitchFamily="34" charset="-120"/>
               </a:rPr>
-              <a:t>   UC2 · 2.5 · 2.6 · 2.7</a:t>
+              <a:t xml:space="preserve">   UC2 · 2.5 · 2.6 · 2.7</a:t>
             </a:r>
             <a:endParaRPr lang="en-US" sz="1100" dirty="0"/>
           </a:p>
@@ -43381,7 +43381,7 @@
       </p:sp>
       <p:pic>
         <p:nvPicPr>
-          <p:cNvPr id="20" name="Image 3" descr="preencoded.png">    </p:cNvPr>
+          <p:cNvPr id="20" name="Image 3" descr="preencoded.png"/>
           <p:cNvPicPr>
             <a:picLocks noChangeAspect="1"/>
           </p:cNvPicPr>
@@ -43450,7 +43450,7 @@
                 <a:ea typeface="Calibri" pitchFamily="34" charset="-122"/>
                 <a:cs typeface="Calibri" pitchFamily="34" charset="-120"/>
               </a:rPr>
-              <a:t>   UC30–32 · UC41–42</a:t>
+              <a:t xml:space="preserve">   UC30–32 · UC41–42</a:t>
             </a:r>
             <a:endParaRPr lang="en-US" sz="1100" dirty="0"/>
           </a:p>
@@ -43517,7 +43517,7 @@
       </p:sp>
       <p:pic>
         <p:nvPicPr>
-          <p:cNvPr id="24" name="Image 4" descr="preencoded.png">    </p:cNvPr>
+          <p:cNvPr id="24" name="Image 4" descr="preencoded.png"/>
           <p:cNvPicPr>
             <a:picLocks noChangeAspect="1"/>
           </p:cNvPicPr>
@@ -43586,7 +43586,7 @@
                 <a:ea typeface="Calibri" pitchFamily="34" charset="-122"/>
                 <a:cs typeface="Calibri" pitchFamily="34" charset="-120"/>
               </a:rPr>
-              <a:t>   UC26 · UC35</a:t>
+              <a:t xml:space="preserve">   UC26 · UC35</a:t>
             </a:r>
             <a:endParaRPr lang="en-US" sz="1100" dirty="0"/>
           </a:p>
@@ -43653,7 +43653,7 @@
       </p:sp>
       <p:pic>
         <p:nvPicPr>
-          <p:cNvPr id="28" name="Image 5" descr="preencoded.png">    </p:cNvPr>
+          <p:cNvPr id="28" name="Image 5" descr="preencoded.png"/>
           <p:cNvPicPr>
             <a:picLocks noChangeAspect="1"/>
           </p:cNvPicPr>
@@ -43722,7 +43722,7 @@
                 <a:ea typeface="Calibri" pitchFamily="34" charset="-122"/>
                 <a:cs typeface="Calibri" pitchFamily="34" charset="-120"/>
               </a:rPr>
-              <a:t>   UC-NHI1–2 · UC19</a:t>
+              <a:t xml:space="preserve">   UC-NHI1–2 · UC19</a:t>
             </a:r>
             <a:endParaRPr lang="en-US" sz="1100" dirty="0"/>
           </a:p>
@@ -44767,7 +44767,7 @@
       </p:sp>
       <p:pic>
         <p:nvPicPr>
-          <p:cNvPr id="11" name="Image 0" descr="preencoded.png">    </p:cNvPr>
+          <p:cNvPr id="11" name="Image 0" descr="preencoded.png"/>
           <p:cNvPicPr>
             <a:picLocks noChangeAspect="1"/>
           </p:cNvPicPr>
@@ -44934,7 +44934,7 @@
       </p:sp>
       <p:pic>
         <p:nvPicPr>
-          <p:cNvPr id="17" name="Image 1" descr="preencoded.png">    </p:cNvPr>
+          <p:cNvPr id="17" name="Image 1" descr="preencoded.png"/>
           <p:cNvPicPr>
             <a:picLocks noChangeAspect="1"/>
           </p:cNvPicPr>
@@ -45101,7 +45101,7 @@
       </p:sp>
       <p:pic>
         <p:nvPicPr>
-          <p:cNvPr id="23" name="Image 2" descr="preencoded.png">    </p:cNvPr>
+          <p:cNvPr id="23" name="Image 2" descr="preencoded.png"/>
           <p:cNvPicPr>
             <a:picLocks noChangeAspect="1"/>
           </p:cNvPicPr>
@@ -45268,7 +45268,7 @@
       </p:sp>
       <p:pic>
         <p:nvPicPr>
-          <p:cNvPr id="29" name="Image 3" descr="preencoded.png">    </p:cNvPr>
+          <p:cNvPr id="29" name="Image 3" descr="preencoded.png"/>
           <p:cNvPicPr>
             <a:picLocks noChangeAspect="1"/>
           </p:cNvPicPr>
@@ -45435,7 +45435,7 @@
       </p:sp>
       <p:pic>
         <p:nvPicPr>
-          <p:cNvPr id="35" name="Image 4" descr="preencoded.png">    </p:cNvPr>
+          <p:cNvPr id="35" name="Image 4" descr="preencoded.png"/>
           <p:cNvPicPr>
             <a:picLocks noChangeAspect="1"/>
           </p:cNvPicPr>
@@ -45602,7 +45602,7 @@
       </p:sp>
       <p:pic>
         <p:nvPicPr>
-          <p:cNvPr id="41" name="Image 5" descr="preencoded.png">    </p:cNvPr>
+          <p:cNvPr id="41" name="Image 5" descr="preencoded.png"/>
           <p:cNvPicPr>
             <a:picLocks noChangeAspect="1"/>
           </p:cNvPicPr>
@@ -45721,7 +45721,7 @@
                 <a:ea typeface="Calibri" pitchFamily="34" charset="-122"/>
                 <a:cs typeface="Calibri" pitchFamily="34" charset="-120"/>
               </a:rPr>
-              <a:t>Optional outer ring:  </a:t>
+              <a:t xml:space="preserve">Optional outer ring:  </a:t>
             </a:r>
             <a:pPr indent="0" marL="0">
               <a:buNone/>
@@ -45735,7 +45735,7 @@
                 <a:ea typeface="Calibri" pitchFamily="34" charset="-122"/>
                 <a:cs typeface="Calibri" pitchFamily="34" charset="-120"/>
               </a:rPr>
-              <a:t>the PingOne Privilege AI Gateway scans prompts for injection and jailbreaks before they reach the model or tools.</a:t>
+              <a:t>the PingOne Agent Privilege scans prompts for injection and jailbreaks before they reach the model or tools.</a:t>
             </a:r>
             <a:endParaRPr lang="en-US" sz="1050" dirty="0"/>
           </a:p>
@@ -47038,7 +47038,7 @@
                 <a:ea typeface="Calibri" pitchFamily="34" charset="-122"/>
                 <a:cs typeface="Calibri" pitchFamily="34" charset="-120"/>
               </a:rPr>
-              <a:t>Optional: PingOne Privilege AI Gateway in front of the agent gateway</a:t>
+              <a:t>Optional: PingOne Agent Privilege in front of the agent gateway</a:t>
             </a:r>
             <a:endParaRPr lang="en-US" sz="950" dirty="0"/>
           </a:p>
@@ -47260,7 +47260,7 @@
       </p:sp>
       <p:pic>
         <p:nvPicPr>
-          <p:cNvPr id="9" name="Image 0" descr="preencoded.png">    </p:cNvPr>
+          <p:cNvPr id="9" name="Image 0" descr="preencoded.png"/>
           <p:cNvPicPr>
             <a:picLocks noChangeAspect="1"/>
           </p:cNvPicPr>
@@ -47315,7 +47315,7 @@
                 <a:ea typeface="Montserrat" pitchFamily="34" charset="-122"/>
                 <a:cs typeface="Montserrat" pitchFamily="34" charset="-120"/>
               </a:rPr>
-              <a:t>AI Gateway for MCP tools</a:t>
+              <a:t>Agent Privilege for MCP tools</a:t>
             </a:r>
             <a:endParaRPr lang="en-US" sz="1300" dirty="0"/>
           </a:p>
@@ -47536,7 +47536,7 @@
       </p:sp>
       <p:pic>
         <p:nvPicPr>
-          <p:cNvPr id="16" name="Image 1" descr="preencoded.png">    </p:cNvPr>
+          <p:cNvPr id="16" name="Image 1" descr="preencoded.png"/>
           <p:cNvPicPr>
             <a:picLocks noChangeAspect="1"/>
           </p:cNvPicPr>
@@ -47823,7 +47823,7 @@
                 <a:ea typeface="Calibri" pitchFamily="34" charset="-122"/>
                 <a:cs typeface="Calibri" pitchFamily="34" charset="-120"/>
               </a:rPr>
-              <a:t>Also:  </a:t>
+              <a:t xml:space="preserve">Also:  </a:t>
             </a:r>
             <a:pPr indent="0" marL="0">
               <a:buNone/>

</xml_diff>